<commit_message>
Deck screenshots from the merged build; receipt photo fits its column; paused-run capture
- app.css: the label photo in the item panel is capped at its column
  (it overflowed into the warranty column below 1500 px).
- record_demo.py: the paused beat saves design/deck/assets/screens/flow-paused.png
  before the cursor enters the frame.
- design/deck/assets/screens, docs/deck: fresh captures (photos, the paused
  run, the completed run, the activity log) and the rebuilt PPTX + previews.

Co-Authored-By: Claude Fable 5.1 <noreply@anthropic.com>
</commit_message>
<xml_diff>
--- a/docs/deck/Guardian-Demo-Deck.pptx
+++ b/docs/deck/Guardian-Demo-Deck.pptx
@@ -11909,7 +11909,7 @@
         <p:spPr>
           <a:xfrm>
             <a:off x="4178196" y="596885"/>
-            <a:ext cx="7518211" cy="5293782"/>
+            <a:ext cx="7518211" cy="4708407"/>
           </a:xfrm>
           <a:prstGeom prst="roundRect">
             <a:avLst>
@@ -11964,7 +11964,7 @@
         <p:spPr>
           <a:xfrm>
             <a:off x="4190895" y="609584"/>
-            <a:ext cx="7492812" cy="5268383"/>
+            <a:ext cx="7492812" cy="4683008"/>
           </a:xfrm>
           <a:prstGeom prst="rect">
             <a:avLst/>
@@ -12302,7 +12302,7 @@
         <p:spPr>
           <a:xfrm>
             <a:off x="4178196" y="596885"/>
-            <a:ext cx="7518211" cy="4708407"/>
+            <a:ext cx="7518211" cy="4240106"/>
           </a:xfrm>
           <a:prstGeom prst="roundRect">
             <a:avLst>
@@ -12342,7 +12342,7 @@
       </p:sp>
       <p:pic>
         <p:nvPicPr>
-          <p:cNvPr id="11" name="Picture 10" descr="trace-tasks-gate.png"/>
+          <p:cNvPr id="11" name="Picture 10" descr="flow-paused.png"/>
           <p:cNvPicPr>
             <a:picLocks noChangeAspect="1"/>
           </p:cNvPicPr>
@@ -12357,7 +12357,7 @@
         <p:spPr>
           <a:xfrm>
             <a:off x="4190895" y="609584"/>
-            <a:ext cx="7492812" cy="4683008"/>
+            <a:ext cx="7492812" cy="4214707"/>
           </a:xfrm>
           <a:prstGeom prst="rect">
             <a:avLst/>
@@ -12695,7 +12695,7 @@
         <p:spPr>
           <a:xfrm>
             <a:off x="4178196" y="596885"/>
-            <a:ext cx="7518211" cy="5293782"/>
+            <a:ext cx="7518211" cy="4708407"/>
           </a:xfrm>
           <a:prstGeom prst="roundRect">
             <a:avLst>
@@ -12750,7 +12750,7 @@
         <p:spPr>
           <a:xfrm>
             <a:off x="4190895" y="609584"/>
-            <a:ext cx="7492812" cy="5268383"/>
+            <a:ext cx="7492812" cy="4683008"/>
           </a:xfrm>
           <a:prstGeom prst="rect">
             <a:avLst/>
@@ -13088,7 +13088,7 @@
         <p:spPr>
           <a:xfrm>
             <a:off x="4178196" y="596885"/>
-            <a:ext cx="7518211" cy="5293782"/>
+            <a:ext cx="7518211" cy="4708407"/>
           </a:xfrm>
           <a:prstGeom prst="roundRect">
             <a:avLst>
@@ -13143,7 +13143,7 @@
         <p:spPr>
           <a:xfrm>
             <a:off x="4190895" y="609584"/>
-            <a:ext cx="7492812" cy="5268383"/>
+            <a:ext cx="7492812" cy="4683008"/>
           </a:xfrm>
           <a:prstGeom prst="rect">
             <a:avLst/>
@@ -13481,7 +13481,7 @@
         <p:spPr>
           <a:xfrm>
             <a:off x="4178196" y="596885"/>
-            <a:ext cx="7518211" cy="5293782"/>
+            <a:ext cx="7518211" cy="4708407"/>
           </a:xfrm>
           <a:prstGeom prst="roundRect">
             <a:avLst>
@@ -13536,7 +13536,7 @@
         <p:spPr>
           <a:xfrm>
             <a:off x="4190895" y="609584"/>
-            <a:ext cx="7492812" cy="5268383"/>
+            <a:ext cx="7492812" cy="4683008"/>
           </a:xfrm>
           <a:prstGeom prst="rect">
             <a:avLst/>

</xml_diff>

<commit_message>
Logo from the avatar geometry with a hairline ring; smoother video; node cards fit; fonts embedded
- ui/Logo.tsx is an SVG with the geometry of design/avatars and favicon.svg
  (lid at (38,16) open, (29.8,24) closed, dot at (12,34)); a 1 px paper
  box-shadow replaces the thick inset ring; the lid animates in CSS
  (.g-logo* in app.css) and the dot pulses while a sweep runs.
- favicon.svg gets the same thin ring; design/README documents the mark.
- Deck and slides share logo_svg(); the deck logo PNG is rendered from it.
- Graph slide: long node ids and labels get smaller sizes instead of
  overflowing the card (video and PPTX); the PPTX now embeds the brand fonts.
- Video: every boundary is a crossfade, the demo title cards hold 5 s and
  show only the lead line, fade in from and out to black; timeline and
  script follow the dissolves.
- deploy_ec2.py ships ANTHROPIC_BASE_URL and ANTHROPIC_AUTH_TOKEN when set.

Co-Authored-By: Claude Fable 5.1 <noreply@anthropic.com>
</commit_message>
<xml_diff>
--- a/docs/deck/Guardian-Demo-Deck.pptx
+++ b/docs/deck/Guardian-Demo-Deck.pptx
@@ -4370,7 +4370,7 @@
       <p:grpSpPr/>
       <p:pic>
         <p:nvPicPr>
-          <p:cNvPr id="2" name="Picture 1" descr="logo.png"/>
+          <p:cNvPr id="2" name="Picture 1" descr="logo-nightwatch.png"/>
           <p:cNvPicPr>
             <a:picLocks noChangeAspect="1"/>
           </p:cNvPicPr>
@@ -4845,8 +4845,8 @@
         </p:nvSpPr>
         <p:spPr>
           <a:xfrm>
-            <a:off x="825479" y="2101797"/>
-            <a:ext cx="1460463" cy="228594"/>
+            <a:off x="812779" y="2101797"/>
+            <a:ext cx="1485862" cy="228594"/>
           </a:xfrm>
           <a:prstGeom prst="rect">
             <a:avLst/>
@@ -4861,7 +4861,7 @@
           <a:p>
             <a:pPr algn="l"/>
             <a:r>
-              <a:rPr sz="1299" b="1" i="0">
+              <a:rPr sz="1149" b="1" i="0">
                 <a:solidFill>
                   <a:srgbClr val="F7F4F3"/>
                 </a:solidFill>
@@ -4880,8 +4880,8 @@
         </p:nvSpPr>
         <p:spPr>
           <a:xfrm>
-            <a:off x="825479" y="2355791"/>
-            <a:ext cx="1460463" cy="190495"/>
+            <a:off x="812779" y="2355791"/>
+            <a:ext cx="1485862" cy="190495"/>
           </a:xfrm>
           <a:prstGeom prst="rect">
             <a:avLst/>
@@ -4896,7 +4896,7 @@
           <a:p>
             <a:pPr algn="l"/>
             <a:r>
-              <a:rPr sz="1049" b="0" i="0" spc="100">
+              <a:rPr sz="999" b="0" i="0" spc="100">
                 <a:solidFill>
                   <a:srgbClr val="B9C3BD"/>
                 </a:solidFill>
@@ -5007,8 +5007,8 @@
         </p:nvSpPr>
         <p:spPr>
           <a:xfrm>
-            <a:off x="825479" y="2800279"/>
-            <a:ext cx="1460463" cy="228594"/>
+            <a:off x="812779" y="2800279"/>
+            <a:ext cx="1485862" cy="228594"/>
           </a:xfrm>
           <a:prstGeom prst="rect">
             <a:avLst/>
@@ -5042,8 +5042,8 @@
         </p:nvSpPr>
         <p:spPr>
           <a:xfrm>
-            <a:off x="825479" y="3054273"/>
-            <a:ext cx="1460463" cy="190495"/>
+            <a:off x="812779" y="3054273"/>
+            <a:ext cx="1485862" cy="190495"/>
           </a:xfrm>
           <a:prstGeom prst="rect">
             <a:avLst/>
@@ -5058,7 +5058,7 @@
           <a:p>
             <a:pPr algn="l"/>
             <a:r>
-              <a:rPr sz="1049" b="0" i="0" spc="100">
+              <a:rPr sz="999" b="0" i="0" spc="100">
                 <a:solidFill>
                   <a:srgbClr val="B9C3BD"/>
                 </a:solidFill>
@@ -5248,8 +5248,8 @@
         </p:nvSpPr>
         <p:spPr>
           <a:xfrm>
-            <a:off x="2743131" y="2101797"/>
-            <a:ext cx="1460463" cy="228594"/>
+            <a:off x="2730431" y="2101797"/>
+            <a:ext cx="1485862" cy="228594"/>
           </a:xfrm>
           <a:prstGeom prst="rect">
             <a:avLst/>
@@ -5264,7 +5264,7 @@
           <a:p>
             <a:pPr algn="l"/>
             <a:r>
-              <a:rPr sz="1299" b="1" i="0">
+              <a:rPr sz="1149" b="1" i="0">
                 <a:solidFill>
                   <a:srgbClr val="F7F4F3"/>
                 </a:solidFill>
@@ -5283,8 +5283,8 @@
         </p:nvSpPr>
         <p:spPr>
           <a:xfrm>
-            <a:off x="2743131" y="2355791"/>
-            <a:ext cx="1460463" cy="190495"/>
+            <a:off x="2730431" y="2355791"/>
+            <a:ext cx="1485862" cy="190495"/>
           </a:xfrm>
           <a:prstGeom prst="rect">
             <a:avLst/>
@@ -5299,7 +5299,7 @@
           <a:p>
             <a:pPr algn="l"/>
             <a:r>
-              <a:rPr sz="1049" b="0" i="0" spc="100">
+              <a:rPr sz="849" b="0" i="0" spc="100">
                 <a:solidFill>
                   <a:srgbClr val="B9C3BD"/>
                 </a:solidFill>
@@ -5410,8 +5410,8 @@
         </p:nvSpPr>
         <p:spPr>
           <a:xfrm>
-            <a:off x="2743131" y="2800279"/>
-            <a:ext cx="1460463" cy="228594"/>
+            <a:off x="2730431" y="2800279"/>
+            <a:ext cx="1485862" cy="228594"/>
           </a:xfrm>
           <a:prstGeom prst="rect">
             <a:avLst/>
@@ -5445,8 +5445,8 @@
         </p:nvSpPr>
         <p:spPr>
           <a:xfrm>
-            <a:off x="2743131" y="3054273"/>
-            <a:ext cx="1460463" cy="190495"/>
+            <a:off x="2730431" y="3054273"/>
+            <a:ext cx="1485862" cy="190495"/>
           </a:xfrm>
           <a:prstGeom prst="rect">
             <a:avLst/>
@@ -5461,7 +5461,7 @@
           <a:p>
             <a:pPr algn="l"/>
             <a:r>
-              <a:rPr sz="1049" b="0" i="0" spc="100">
+              <a:rPr sz="999" b="0" i="0" spc="100">
                 <a:solidFill>
                   <a:srgbClr val="6FB3E3"/>
                 </a:solidFill>
@@ -5651,8 +5651,8 @@
         </p:nvSpPr>
         <p:spPr>
           <a:xfrm>
-            <a:off x="4660783" y="2451038"/>
-            <a:ext cx="1460463" cy="228594"/>
+            <a:off x="4648083" y="2451038"/>
+            <a:ext cx="1485862" cy="228594"/>
           </a:xfrm>
           <a:prstGeom prst="rect">
             <a:avLst/>
@@ -5686,8 +5686,8 @@
         </p:nvSpPr>
         <p:spPr>
           <a:xfrm>
-            <a:off x="4660783" y="2705032"/>
-            <a:ext cx="1460463" cy="190495"/>
+            <a:off x="4648083" y="2705032"/>
+            <a:ext cx="1485862" cy="190495"/>
           </a:xfrm>
           <a:prstGeom prst="rect">
             <a:avLst/>
@@ -5702,7 +5702,7 @@
           <a:p>
             <a:pPr algn="l"/>
             <a:r>
-              <a:rPr sz="1049" b="0" i="0" spc="100">
+              <a:rPr sz="999" b="0" i="0" spc="100">
                 <a:solidFill>
                   <a:srgbClr val="6FB3E3"/>
                 </a:solidFill>
@@ -5892,8 +5892,8 @@
         </p:nvSpPr>
         <p:spPr>
           <a:xfrm>
-            <a:off x="6578435" y="2451038"/>
-            <a:ext cx="1460463" cy="228594"/>
+            <a:off x="6565735" y="2451038"/>
+            <a:ext cx="1485862" cy="228594"/>
           </a:xfrm>
           <a:prstGeom prst="rect">
             <a:avLst/>
@@ -5927,8 +5927,8 @@
         </p:nvSpPr>
         <p:spPr>
           <a:xfrm>
-            <a:off x="6578435" y="2705032"/>
-            <a:ext cx="1460463" cy="190495"/>
+            <a:off x="6565735" y="2705032"/>
+            <a:ext cx="1485862" cy="190495"/>
           </a:xfrm>
           <a:prstGeom prst="rect">
             <a:avLst/>
@@ -5943,7 +5943,7 @@
           <a:p>
             <a:pPr algn="l"/>
             <a:r>
-              <a:rPr sz="1049" b="0" i="0" spc="100">
+              <a:rPr sz="999" b="0" i="0" spc="100">
                 <a:solidFill>
                   <a:srgbClr val="B9C3BD"/>
                 </a:solidFill>
@@ -6133,8 +6133,8 @@
         </p:nvSpPr>
         <p:spPr>
           <a:xfrm>
-            <a:off x="8496087" y="2451038"/>
-            <a:ext cx="1460463" cy="228594"/>
+            <a:off x="8483387" y="2451038"/>
+            <a:ext cx="1485862" cy="228594"/>
           </a:xfrm>
           <a:prstGeom prst="rect">
             <a:avLst/>
@@ -6168,8 +6168,8 @@
         </p:nvSpPr>
         <p:spPr>
           <a:xfrm>
-            <a:off x="8496087" y="2705032"/>
-            <a:ext cx="1460463" cy="190495"/>
+            <a:off x="8483387" y="2705032"/>
+            <a:ext cx="1485862" cy="190495"/>
           </a:xfrm>
           <a:prstGeom prst="rect">
             <a:avLst/>
@@ -6184,7 +6184,7 @@
           <a:p>
             <a:pPr algn="l"/>
             <a:r>
-              <a:rPr sz="1049" b="0" i="0" spc="100">
+              <a:rPr sz="999" b="0" i="0" spc="100">
                 <a:solidFill>
                   <a:srgbClr val="6FB3E3"/>
                 </a:solidFill>
@@ -6374,8 +6374,8 @@
         </p:nvSpPr>
         <p:spPr>
           <a:xfrm>
-            <a:off x="10413739" y="2451038"/>
-            <a:ext cx="1460463" cy="228594"/>
+            <a:off x="10401039" y="2451038"/>
+            <a:ext cx="1485862" cy="228594"/>
           </a:xfrm>
           <a:prstGeom prst="rect">
             <a:avLst/>
@@ -6409,8 +6409,8 @@
         </p:nvSpPr>
         <p:spPr>
           <a:xfrm>
-            <a:off x="10413739" y="2705032"/>
-            <a:ext cx="1460463" cy="190495"/>
+            <a:off x="10401039" y="2705032"/>
+            <a:ext cx="1485862" cy="190495"/>
           </a:xfrm>
           <a:prstGeom prst="rect">
             <a:avLst/>
@@ -6425,7 +6425,7 @@
           <a:p>
             <a:pPr algn="l"/>
             <a:r>
-              <a:rPr sz="1049" b="0" i="0" spc="100">
+              <a:rPr sz="999" b="0" i="0" spc="100">
                 <a:solidFill>
                   <a:srgbClr val="5DBB86"/>
                 </a:solidFill>
@@ -6723,8 +6723,8 @@
         </p:nvSpPr>
         <p:spPr>
           <a:xfrm>
-            <a:off x="825479" y="4006749"/>
-            <a:ext cx="1460463" cy="228594"/>
+            <a:off x="812779" y="4006749"/>
+            <a:ext cx="1485862" cy="228594"/>
           </a:xfrm>
           <a:prstGeom prst="rect">
             <a:avLst/>
@@ -6739,7 +6739,7 @@
           <a:p>
             <a:pPr algn="l"/>
             <a:r>
-              <a:rPr sz="1149" b="1" i="0">
+              <a:rPr sz="999" b="1" i="0">
                 <a:solidFill>
                   <a:srgbClr val="F7F4F3"/>
                 </a:solidFill>
@@ -6758,8 +6758,8 @@
         </p:nvSpPr>
         <p:spPr>
           <a:xfrm>
-            <a:off x="825479" y="4260743"/>
-            <a:ext cx="1460463" cy="190495"/>
+            <a:off x="812779" y="4260743"/>
+            <a:ext cx="1485862" cy="190495"/>
           </a:xfrm>
           <a:prstGeom prst="rect">
             <a:avLst/>
@@ -6774,7 +6774,7 @@
           <a:p>
             <a:pPr algn="l"/>
             <a:r>
-              <a:rPr sz="1049" b="0" i="0" spc="100">
+              <a:rPr sz="999" b="0" i="0" spc="100">
                 <a:solidFill>
                   <a:srgbClr val="FCBA04"/>
                 </a:solidFill>
@@ -6885,8 +6885,8 @@
         </p:nvSpPr>
         <p:spPr>
           <a:xfrm>
-            <a:off x="825479" y="4705232"/>
-            <a:ext cx="1460463" cy="228594"/>
+            <a:off x="812779" y="4705232"/>
+            <a:ext cx="1485862" cy="228594"/>
           </a:xfrm>
           <a:prstGeom prst="rect">
             <a:avLst/>
@@ -6920,8 +6920,8 @@
         </p:nvSpPr>
         <p:spPr>
           <a:xfrm>
-            <a:off x="825479" y="4959226"/>
-            <a:ext cx="1460463" cy="190495"/>
+            <a:off x="812779" y="4959226"/>
+            <a:ext cx="1485862" cy="190495"/>
           </a:xfrm>
           <a:prstGeom prst="rect">
             <a:avLst/>
@@ -6936,7 +6936,7 @@
           <a:p>
             <a:pPr algn="l"/>
             <a:r>
-              <a:rPr sz="1049" b="0" i="0" spc="100">
+              <a:rPr sz="999" b="0" i="0" spc="100">
                 <a:solidFill>
                   <a:srgbClr val="B9C3BD"/>
                 </a:solidFill>
@@ -7126,8 +7126,8 @@
         </p:nvSpPr>
         <p:spPr>
           <a:xfrm>
-            <a:off x="2743131" y="4355991"/>
-            <a:ext cx="1460463" cy="228594"/>
+            <a:off x="2730431" y="4355991"/>
+            <a:ext cx="1485862" cy="228594"/>
           </a:xfrm>
           <a:prstGeom prst="rect">
             <a:avLst/>
@@ -7161,8 +7161,8 @@
         </p:nvSpPr>
         <p:spPr>
           <a:xfrm>
-            <a:off x="2743131" y="4609984"/>
-            <a:ext cx="1460463" cy="190495"/>
+            <a:off x="2730431" y="4609984"/>
+            <a:ext cx="1485862" cy="190495"/>
           </a:xfrm>
           <a:prstGeom prst="rect">
             <a:avLst/>
@@ -7177,7 +7177,7 @@
           <a:p>
             <a:pPr algn="l"/>
             <a:r>
-              <a:rPr sz="1049" b="0" i="0" spc="100">
+              <a:rPr sz="999" b="0" i="0" spc="100">
                 <a:solidFill>
                   <a:srgbClr val="B9C3BD"/>
                 </a:solidFill>
@@ -7367,8 +7367,8 @@
         </p:nvSpPr>
         <p:spPr>
           <a:xfrm>
-            <a:off x="4660783" y="4355991"/>
-            <a:ext cx="1460463" cy="228594"/>
+            <a:off x="4648083" y="4355991"/>
+            <a:ext cx="1485862" cy="228594"/>
           </a:xfrm>
           <a:prstGeom prst="rect">
             <a:avLst/>
@@ -7402,8 +7402,8 @@
         </p:nvSpPr>
         <p:spPr>
           <a:xfrm>
-            <a:off x="4660783" y="4609984"/>
-            <a:ext cx="1460463" cy="190495"/>
+            <a:off x="4648083" y="4609984"/>
+            <a:ext cx="1485862" cy="190495"/>
           </a:xfrm>
           <a:prstGeom prst="rect">
             <a:avLst/>
@@ -7418,7 +7418,7 @@
           <a:p>
             <a:pPr algn="l"/>
             <a:r>
-              <a:rPr sz="1049" b="0" i="0" spc="100">
+              <a:rPr sz="999" b="0" i="0" spc="100">
                 <a:solidFill>
                   <a:srgbClr val="6FB3E3"/>
                 </a:solidFill>
@@ -7608,8 +7608,8 @@
         </p:nvSpPr>
         <p:spPr>
           <a:xfrm>
-            <a:off x="6578435" y="4355991"/>
-            <a:ext cx="1460463" cy="228594"/>
+            <a:off x="6565735" y="4355991"/>
+            <a:ext cx="1485862" cy="228594"/>
           </a:xfrm>
           <a:prstGeom prst="rect">
             <a:avLst/>
@@ -7643,8 +7643,8 @@
         </p:nvSpPr>
         <p:spPr>
           <a:xfrm>
-            <a:off x="6578435" y="4609984"/>
-            <a:ext cx="1460463" cy="190495"/>
+            <a:off x="6565735" y="4609984"/>
+            <a:ext cx="1485862" cy="190495"/>
           </a:xfrm>
           <a:prstGeom prst="rect">
             <a:avLst/>
@@ -7659,7 +7659,7 @@
           <a:p>
             <a:pPr algn="l"/>
             <a:r>
-              <a:rPr sz="1049" b="0" i="0" spc="100">
+              <a:rPr sz="849" b="0" i="0" spc="100">
                 <a:solidFill>
                   <a:srgbClr val="B9C3BD"/>
                 </a:solidFill>
@@ -9741,7 +9741,7 @@
       <p:grpSpPr/>
       <p:pic>
         <p:nvPicPr>
-          <p:cNvPr id="2" name="Picture 1" descr="logo.png"/>
+          <p:cNvPr id="2" name="Picture 1" descr="logo-nightwatch.png"/>
           <p:cNvPicPr>
             <a:picLocks noChangeAspect="1"/>
           </p:cNvPicPr>

</xml_diff>

<commit_message>
Final live recording: deck screenshots from the live site, rebuilt PPTX and previews, script with the final timecodes
Co-Authored-By: Claude Fable 5.1 <noreply@anthropic.com>
</commit_message>
<xml_diff>
--- a/docs/deck/Guardian-Demo-Deck.pptx
+++ b/docs/deck/Guardian-Demo-Deck.pptx
@@ -12302,7 +12302,7 @@
         <p:spPr>
           <a:xfrm>
             <a:off x="4178196" y="596885"/>
-            <a:ext cx="7518211" cy="4240106"/>
+            <a:ext cx="7518211" cy="4708407"/>
           </a:xfrm>
           <a:prstGeom prst="roundRect">
             <a:avLst>
@@ -12357,7 +12357,7 @@
         <p:spPr>
           <a:xfrm>
             <a:off x="4190895" y="609584"/>
-            <a:ext cx="7492812" cy="4214707"/>
+            <a:ext cx="7492812" cy="4683008"/>
           </a:xfrm>
           <a:prstGeom prst="rect">
             <a:avLst/>

</xml_diff>

<commit_message>
Deck: the sweep slide shows the paused run from the live recording; screens keeps that capture unless a run waits
Co-Authored-By: Claude Fable 5.1 <noreply@anthropic.com>
</commit_message>
<xml_diff>
--- a/docs/deck/Guardian-Demo-Deck.pptx
+++ b/docs/deck/Guardian-Demo-Deck.pptx
@@ -12302,7 +12302,7 @@
         <p:spPr>
           <a:xfrm>
             <a:off x="4178196" y="596885"/>
-            <a:ext cx="7518211" cy="4708407"/>
+            <a:ext cx="7518211" cy="4240106"/>
           </a:xfrm>
           <a:prstGeom prst="roundRect">
             <a:avLst>
@@ -12357,7 +12357,7 @@
         <p:spPr>
           <a:xfrm>
             <a:off x="4190895" y="609584"/>
-            <a:ext cx="7492812" cy="4683008"/>
+            <a:ext cx="7492812" cy="4214707"/>
           </a:xfrm>
           <a:prstGeom prst="rect">
             <a:avLst/>

</xml_diff>

<commit_message>
Narration re-paced by syllables; teleprompter; take assembly tool
- Narration blocks sit at 2.7 to 3.8 syllables a second (several were over 4);
  the fast slides hold a few seconds longer; the video is 4:56.
- record_demo.py prompter writes docs/teleprompter.html: the words advance by
  syllable weight with breaths at punctuation, the muted video plays beside
  the text, Space starts a 3-2-1 count. The script's pace column shows
  syllables a second.
- scripts/narration.py: transcribe several takes (faster-whisper), pick the
  best take per block (accuracy, fit, same voice), cut and place each block
  at its timecode, normalise, mux the final MP4. Proven on two synthetic takes.

Co-Authored-By: Claude Fable 5.1 <noreply@anthropic.com>
</commit_message>
<xml_diff>
--- a/docs/deck/Guardian-Demo-Deck.pptx
+++ b/docs/deck/Guardian-Demo-Deck.pptx
@@ -584,7 +584,7 @@
           <a:lstStyle/>
           <a:p>
             <a:r>
-              <a:t>The nightly sweep is thirteen nodes. Feed pagination, VIN decoding, UPC equality, sold-window arithmetic and the notification budget are code. Deciding whether a listing is the recalled product, or whether a plan is worth an interruption, is an agent, and every agent output is a validated structured object. A quiet night skips every agent node: zero model calls.</a:t>
+              <a:t>The nightly sweep is thirteen nodes. Feed paging, VIN decoding, UPC matching and the notification budget are all code. Deciding whether a listing is the recalled product, or whether a plan is worth an interruption, that is an agent. Every agent output is a validated object. A quiet night skips the agents entirely: zero model calls.</a:t>
             </a:r>
           </a:p>
         </p:txBody>
@@ -654,7 +654,7 @@
           <a:lstStyle/>
           <a:p>
             <a:r>
-              <a:t>On Strands: every node is a MultiAgentBase executor in a GraphBuilder. Edges come from data references, with AND-join conditions. The gate is a Strands interrupt that survives a process exit. The verifier has kill authority with one bounded repair round, and side effects run once, behind the gate.</a:t>
+              <a:t>On Strands, every node is a MultiAgentBase executor. Edges come from data references, with AND-join conditions. The gate is a Strands interrupt that survives a process exit. The verifier has kill authority, with one bounded repair round. And side effects run once, behind the gate.</a:t>
             </a:r>
           </a:p>
         </p:txBody>
@@ -724,7 +724,7 @@
           <a:lstStyle/>
           <a:p>
             <a:r>
-              <a:t>A real first sweep on live feeds: 594 CPSC recalls, 1,200 openFDA reports, 7,143 pairs checked in code, eight matches, paused at the gate after 235 seconds and 41 cents.</a:t>
+              <a:t>A real first sweep on live feeds: five hundred ninety-four CPSC recalls, twelve hundred openFDA reports, seven thousand pairs checked in code, eight matches, and a pause at the gate after four minutes and forty-one cents.</a:t>
             </a:r>
           </a:p>
         </p:txBody>
@@ -864,7 +864,7 @@
           <a:lstStyle/>
           <a:p>
             <a:r>
-              <a:t>Recalls exist because products injure people. The remedies are free: refunds, repair kits, replacement parts. Most go unclaimed, because a recall is broadcast to everyone and matched to nobody. CPSC alone published 594 recalls in one 400-day window, and the receipt that proves you own the product sits in an email nobody opens again.</a:t>
+              <a:t>Recalls exist because products hurt people. The remedies are free: refunds, repair kits, replacement parts. Most go unclaimed, because a recall is broadcast to everyone and matched to no one. CPSC alone published nearly six hundred recalls in the last thirteen months. And the receipt that proves you own the product sits in an email nobody opens.</a:t>
             </a:r>
           </a:p>
         </p:txBody>
@@ -934,7 +934,7 @@
           <a:lstStyle/>
           <a:p>
             <a:r>
-              <a:t>Guardian is for the household's default administrator: the parent of a young child, the car owner, anyone with appliances. Not another app to keep open. One text with one decision, only when something they own is affected.</a:t>
+              <a:t>Guardian is for the person who runs the household: the parent of a young child, the car owner, anyone with appliances. Not another app to keep open. One text, one decision, only when something they own is affected.</a:t>
             </a:r>
           </a:p>
         </p:txBody>
@@ -1004,7 +1004,7 @@
           <a:lstStyle/>
           <a:p>
             <a:r>
-              <a:t>Four steps. Capture a receipt, or a car by VIN. Watch: every night a Strands graph pulls CPSC, NHTSA and openFDA and matches them in code; only ambiguous pairs reach a model. Decide: a triage agent picks what deserves an interruption; a verifier checks it. Act: after one approval, Guardian sends the remedy request, receipt attached.</a:t>
+              <a:t>Capture: forward a receipt, or add a car by its VIN. Watch: every night, a Strands graph pulls the government recall feeds and matches them in code. Only ambiguous pairs reach a model. Decide: a triage agent picks what deserves an interruption, and a verifier checks it. Act: after one approval, Guardian sends the remedy request, receipt attached.</a:t>
             </a:r>
           </a:p>
         </p:txBody>
@@ -1074,7 +1074,7 @@
           <a:lstStyle/>
           <a:p>
             <a:r>
-              <a:t>Here it is on the live site. Twelve items, seeded from real receipts and a VIN. Intake redacts card numbers and extracts brand, model, UPC, purchase date, retailer and warranty term. Select an item: its receipt, its warranty window, and its recall checks. None yet: tonight's sweep has not run.</a:t>
+              <a:t>Here it is on the live site. Twelve items, seeded from real receipts and one VIN. Intake redacts the card numbers, then pulls out the brand, model, UPC, purchase date, retailer and warranty term. Select an item and you see its receipt, its warranty window, and its recall checks. None yet, because tonight's sweep has not run.</a:t>
             </a:r>
           </a:p>
         </p:txBody>
@@ -1144,7 +1144,7 @@
           <a:lstStyle/>
           <a:p>
             <a:r>
-              <a:t>One click starts the sweep, and this is the run as the Strands graph sees it, streamed live. Grey nodes are code, blue are agents, green is the verifier, amber is the human gate. Feeds refresh, candidates are generated in code, the matcher adjudicates only the ambiguous pairs, triage decides what deserves an interruption tonight, and the verifier checks the plan; it can send it back once. Two minutes in, the run pauses at the household gate. The checkpoint is on disk, the timeline shows the wait, and nothing downstream can run without an approval record.</a:t>
+              <a:t>One click starts the sweep, and this is the run exactly as the Strands graph sees it, streamed live. Grey nodes are code. Blue nodes are agents. Green is the verifier, and amber is the human gate. The feeds refresh, candidates are generated in code, the matcher judges only the ambiguous pairs, triage decides what deserves an interruption tonight, and the verifier checks the plan. It can send the plan back once. Two minutes in, the run pauses at the household gate. The checkpoint is on disk, the timeline shows the wait, and nothing downstream can run without an approval record.</a:t>
             </a:r>
           </a:p>
         </p:txBody>
@@ -1214,7 +1214,7 @@
           <a:lstStyle/>
           <a:p>
             <a:r>
-              <a:t>The morning after. The quiet score is the headline metric: days since Guardian last needed you. Today it is zero, because a critical recall matched. Twelve items watched, nearly two thousand recalls screened, and the sweep log shows each step.</a:t>
+              <a:t>The morning after. The quiet score is the headline metric: the days since Guardian last needed you. Today it is zero, because a critical recall matched. Twelve items watched, nearly two thousand recalls screened, and the sweep log shows every step.</a:t>
             </a:r>
           </a:p>
         </p:txBody>
@@ -1284,7 +1284,7 @@
           <a:lstStyle/>
           <a:p>
             <a:r>
-              <a:t>One decision. This is the same card the phone points to. The recall is real, the remedy request is already drafted with the receipt attached, and the reasoning is one click away. One tap: request the refund. The graph resumes, the remedy agent writes the request from the recall's own contact, sends it once, and schedules the follow-up.</a:t>
+              <a:t>One decision. This is the same card the phone points to. The recall is real, the remedy request is already drafted, receipt attached, and the reasoning is one click away. One tap: request the refund. The graph resumes. The remedy agent writes the request to the recall's own contact, sends it once, and schedules the follow-up.</a:t>
             </a:r>
           </a:p>
         </p:txBody>
@@ -1354,7 +1354,7 @@
           <a:lstStyle/>
           <a:p>
             <a:r>
-              <a:t>After the approval the run completes: the remedy is sent and the follow-up is scheduled. The timeline keeps the human wait as its own bar, apart from machine time. And every sweep is logged, including the ones that found nothing: three NHTSA campaigns on the household's Subaru went to the weekly digest with no interruption.</a:t>
+              <a:t>After the approval, the run completes: the remedy is sent and the follow-up is scheduled. The timeline shows the human wait as its own bar. And every sweep is logged, even the ones that found nothing. Three NHTSA campaigns on the household's Subaru went to the weekly digest, with no interruption.</a:t>
             </a:r>
           </a:p>
         </p:txBody>

</xml_diff>